<commit_message>
Final modification in PPT
</commit_message>
<xml_diff>
--- a/source/MySEProject/Documentation/Fusion_CodersPPT.pptx
+++ b/source/MySEProject/Documentation/Fusion_CodersPPT.pptx
@@ -10,13 +10,14 @@
     <p:sldId id="259" r:id="rId4"/>
     <p:sldId id="261" r:id="rId5"/>
     <p:sldId id="262" r:id="rId6"/>
-    <p:sldId id="263" r:id="rId7"/>
-    <p:sldId id="264" r:id="rId8"/>
-    <p:sldId id="265" r:id="rId9"/>
-    <p:sldId id="268" r:id="rId10"/>
+    <p:sldId id="271" r:id="rId7"/>
+    <p:sldId id="263" r:id="rId8"/>
+    <p:sldId id="264" r:id="rId9"/>
+    <p:sldId id="265" r:id="rId10"/>
     <p:sldId id="266" r:id="rId11"/>
-    <p:sldId id="267" r:id="rId12"/>
-    <p:sldId id="270" r:id="rId13"/>
+    <p:sldId id="268" r:id="rId12"/>
+    <p:sldId id="267" r:id="rId13"/>
+    <p:sldId id="270" r:id="rId14"/>
   </p:sldIdLst>
   <p:sldSz cx="12192000" cy="6858000"/>
   <p:notesSz cx="6858000" cy="9144000"/>
@@ -380,7 +381,7 @@
           <a:p>
             <a:fld id="{3341EE12-F28E-4B03-A404-A8FCAE0F6316}" type="datetime1">
               <a:rPr lang="en-US" smtClean="0"/>
-              <a:t>3/22/2025</a:t>
+              <a:t>3/23/2025</a:t>
             </a:fld>
             <a:endParaRPr lang="en-US" dirty="0"/>
           </a:p>
@@ -665,7 +666,7 @@
           <a:p>
             <a:fld id="{B68B8189-0D9C-48A6-9FA3-862227B094CE}" type="datetime1">
               <a:rPr lang="en-US" smtClean="0"/>
-              <a:t>3/22/2025</a:t>
+              <a:t>3/23/2025</a:t>
             </a:fld>
             <a:endParaRPr lang="en-US"/>
           </a:p>
@@ -1029,7 +1030,7 @@
           <a:p>
             <a:fld id="{26ADDCAE-6443-42C3-9C19-F95985500186}" type="datetime1">
               <a:rPr lang="en-US" smtClean="0"/>
-              <a:t>3/22/2025</a:t>
+              <a:t>3/23/2025</a:t>
             </a:fld>
             <a:endParaRPr lang="en-US" dirty="0"/>
           </a:p>
@@ -1291,7 +1292,7 @@
           <a:p>
             <a:fld id="{1962799E-EB8E-4038-8063-81BB57C732D4}" type="datetime1">
               <a:rPr lang="en-US" smtClean="0"/>
-              <a:t>3/22/2025</a:t>
+              <a:t>3/23/2025</a:t>
             </a:fld>
             <a:endParaRPr lang="en-US"/>
           </a:p>
@@ -1721,7 +1722,7 @@
           <a:p>
             <a:fld id="{217A73C3-B243-44D3-809D-EF8FDFBD85D4}" type="datetime1">
               <a:rPr lang="en-US" smtClean="0"/>
-              <a:t>3/22/2025</a:t>
+              <a:t>3/23/2025</a:t>
             </a:fld>
             <a:endParaRPr lang="en-US" dirty="0"/>
           </a:p>
@@ -2052,7 +2053,7 @@
           <a:p>
             <a:fld id="{C9B6D3E3-28E2-4380-A113-67698215C5F8}" type="datetime1">
               <a:rPr lang="en-US" smtClean="0"/>
-              <a:t>3/22/2025</a:t>
+              <a:t>3/23/2025</a:t>
             </a:fld>
             <a:endParaRPr lang="en-US" dirty="0"/>
           </a:p>
@@ -2485,7 +2486,7 @@
           <a:p>
             <a:fld id="{A9EFCB61-04AD-47C9-BF79-2BD8B9CEC07A}" type="datetime1">
               <a:rPr lang="en-US" smtClean="0"/>
-              <a:t>3/22/2025</a:t>
+              <a:t>3/23/2025</a:t>
             </a:fld>
             <a:endParaRPr lang="en-US" dirty="0"/>
           </a:p>
@@ -2637,7 +2638,7 @@
           <a:p>
             <a:fld id="{A4535E0C-D585-492F-8146-7493F4086301}" type="datetime1">
               <a:rPr lang="en-US" smtClean="0"/>
-              <a:t>3/22/2025</a:t>
+              <a:t>3/23/2025</a:t>
             </a:fld>
             <a:endParaRPr lang="en-US"/>
           </a:p>
@@ -2800,7 +2801,7 @@
           <a:p>
             <a:fld id="{8CE48390-48B5-49AB-B019-A7C8FB8C31F6}" type="datetime1">
               <a:rPr lang="en-US" smtClean="0"/>
-              <a:t>3/22/2025</a:t>
+              <a:t>3/23/2025</a:t>
             </a:fld>
             <a:endParaRPr lang="en-US"/>
           </a:p>
@@ -3329,7 +3330,7 @@
           <a:p>
             <a:fld id="{962E767E-8A14-4E70-91B9-2101CBC4D7BD}" type="datetime1">
               <a:rPr lang="en-US" smtClean="0"/>
-              <a:t>3/22/2025</a:t>
+              <a:t>3/23/2025</a:t>
             </a:fld>
             <a:endParaRPr lang="en-US" dirty="0"/>
           </a:p>
@@ -3850,7 +3851,7 @@
           <a:p>
             <a:fld id="{01AF0C4B-5A4A-45CA-ABEC-10F107160D33}" type="datetime1">
               <a:rPr lang="en-US" smtClean="0"/>
-              <a:t>3/22/2025</a:t>
+              <a:t>3/23/2025</a:t>
             </a:fld>
             <a:endParaRPr lang="en-US" dirty="0"/>
           </a:p>
@@ -4400,7 +4401,7 @@
           <a:p>
             <a:fld id="{6989806E-8E94-473C-AEE7-BE6F15F85533}" type="datetime1">
               <a:rPr lang="en-US" smtClean="0"/>
-              <a:t>3/22/2025</a:t>
+              <a:t>3/23/2025</a:t>
             </a:fld>
             <a:endParaRPr lang="en-US" dirty="0"/>
           </a:p>
@@ -4919,7 +4920,7 @@
           <p:nvPr/>
         </p:nvPicPr>
         <p:blipFill>
-          <a:blip r:embed="rId2">
+          <a:blip r:embed="rId3">
             <a:extLst>
               <a:ext uri="{28A0092B-C50C-407E-A947-70E740481C1C}">
                 <a14:useLocalDpi xmlns:a14="http://schemas.microsoft.com/office/drawing/2010/main" val="0"/>
@@ -4955,7 +4956,7 @@
           <p:nvPr/>
         </p:nvPicPr>
         <p:blipFill>
-          <a:blip r:embed="rId3">
+          <a:blip r:embed="rId4">
             <a:extLst>
               <a:ext uri="{28A0092B-C50C-407E-A947-70E740481C1C}">
                 <a14:useLocalDpi xmlns:a14="http://schemas.microsoft.com/office/drawing/2010/main" val="0"/>
@@ -4977,6 +4978,9 @@
         </p:spPr>
       </p:pic>
     </p:spTree>
+    <p:custDataLst>
+      <p:tags r:id="rId1"/>
+    </p:custDataLst>
     <p:extLst>
       <p:ext uri="{BB962C8B-B14F-4D97-AF65-F5344CB8AC3E}">
         <p14:creationId xmlns:p14="http://schemas.microsoft.com/office/powerpoint/2010/main" val="3641864967"/>
@@ -5145,7 +5149,7 @@
           <p:nvPr/>
         </p:nvPicPr>
         <p:blipFill>
-          <a:blip r:embed="rId2">
+          <a:blip r:embed="rId3">
             <a:extLst>
               <a:ext uri="{28A0092B-C50C-407E-A947-70E740481C1C}">
                 <a14:useLocalDpi xmlns:a14="http://schemas.microsoft.com/office/drawing/2010/main" val="0"/>
@@ -5429,7 +5433,7 @@
           <p:nvPr/>
         </p:nvPicPr>
         <p:blipFill>
-          <a:blip r:embed="rId3">
+          <a:blip r:embed="rId4">
             <a:extLst>
               <a:ext uri="{28A0092B-C50C-407E-A947-70E740481C1C}">
                 <a14:useLocalDpi xmlns:a14="http://schemas.microsoft.com/office/drawing/2010/main" val="0"/>
@@ -5451,6 +5455,9 @@
         </p:spPr>
       </p:pic>
     </p:spTree>
+    <p:custDataLst>
+      <p:tags r:id="rId1"/>
+    </p:custDataLst>
     <p:extLst>
       <p:ext uri="{BB962C8B-B14F-4D97-AF65-F5344CB8AC3E}">
         <p14:creationId xmlns:p14="http://schemas.microsoft.com/office/powerpoint/2010/main" val="1079327904"/>
@@ -5763,6 +5770,271 @@
   <p:cSld>
     <p:spTree>
       <p:nvGrpSpPr>
+        <p:cNvPr id="1" name=""/>
+        <p:cNvGrpSpPr/>
+        <p:nvPr/>
+      </p:nvGrpSpPr>
+      <p:grpSpPr>
+        <a:xfrm>
+          <a:off x="0" y="0"/>
+          <a:ext cx="0" cy="0"/>
+          <a:chOff x="0" y="0"/>
+          <a:chExt cx="0" cy="0"/>
+        </a:xfrm>
+      </p:grpSpPr>
+      <p:pic>
+        <p:nvPicPr>
+          <p:cNvPr id="3" name="Picture 2" descr="A computer screen with a blue background&#10;&#10;AI-generated content may be incorrect.">
+            <a:extLst>
+              <a:ext uri="{FF2B5EF4-FFF2-40B4-BE49-F238E27FC236}">
+                <a16:creationId xmlns:a16="http://schemas.microsoft.com/office/drawing/2014/main" id="{CCAB805E-8BC0-187C-C05B-C1ABCE3BC391}"/>
+              </a:ext>
+            </a:extLst>
+          </p:cNvPr>
+          <p:cNvPicPr>
+            <a:picLocks noChangeAspect="1"/>
+          </p:cNvPicPr>
+          <p:nvPr/>
+        </p:nvPicPr>
+        <p:blipFill>
+          <a:blip r:embed="rId3">
+            <a:extLst>
+              <a:ext uri="{28A0092B-C50C-407E-A947-70E740481C1C}">
+                <a14:useLocalDpi xmlns:a14="http://schemas.microsoft.com/office/drawing/2010/main" val="0"/>
+              </a:ext>
+            </a:extLst>
+          </a:blip>
+          <a:stretch>
+            <a:fillRect/>
+          </a:stretch>
+        </p:blipFill>
+        <p:spPr>
+          <a:xfrm>
+            <a:off x="0" y="0"/>
+            <a:ext cx="12192000" cy="6958361"/>
+          </a:xfrm>
+          <a:prstGeom prst="rect">
+            <a:avLst/>
+          </a:prstGeom>
+        </p:spPr>
+      </p:pic>
+      <p:sp>
+        <p:nvSpPr>
+          <p:cNvPr id="4" name="TextBox 3">
+            <a:extLst>
+              <a:ext uri="{FF2B5EF4-FFF2-40B4-BE49-F238E27FC236}">
+                <a16:creationId xmlns:a16="http://schemas.microsoft.com/office/drawing/2014/main" id="{CCF86807-66AF-9FB0-9E5C-420F9854BE19}"/>
+              </a:ext>
+            </a:extLst>
+          </p:cNvPr>
+          <p:cNvSpPr txBox="1"/>
+          <p:nvPr/>
+        </p:nvSpPr>
+        <p:spPr>
+          <a:xfrm>
+            <a:off x="591015" y="557560"/>
+            <a:ext cx="5988205" cy="646331"/>
+          </a:xfrm>
+          <a:prstGeom prst="rect">
+            <a:avLst/>
+          </a:prstGeom>
+          <a:noFill/>
+        </p:spPr>
+        <p:txBody>
+          <a:bodyPr wrap="square" rtlCol="0">
+            <a:spAutoFit/>
+          </a:bodyPr>
+          <a:lstStyle/>
+          <a:p>
+            <a:r>
+              <a:rPr lang="en-US" sz="3600" b="1" dirty="0">
+                <a:solidFill>
+                  <a:schemeClr val="bg1"/>
+                </a:solidFill>
+              </a:rPr>
+              <a:t>Output of the Project:</a:t>
+            </a:r>
+          </a:p>
+        </p:txBody>
+      </p:sp>
+      <p:pic>
+        <p:nvPicPr>
+          <p:cNvPr id="6" name="Picture 5" descr="A screenshot of a computer program&#10;&#10;AI-generated content may be incorrect.">
+            <a:extLst>
+              <a:ext uri="{FF2B5EF4-FFF2-40B4-BE49-F238E27FC236}">
+                <a16:creationId xmlns:a16="http://schemas.microsoft.com/office/drawing/2014/main" id="{30AE157F-A35F-E44F-0D11-AAF92BF3F619}"/>
+              </a:ext>
+            </a:extLst>
+          </p:cNvPr>
+          <p:cNvPicPr>
+            <a:picLocks noChangeAspect="1"/>
+          </p:cNvPicPr>
+          <p:nvPr/>
+        </p:nvPicPr>
+        <p:blipFill>
+          <a:blip r:embed="rId4">
+            <a:extLst>
+              <a:ext uri="{28A0092B-C50C-407E-A947-70E740481C1C}">
+                <a14:useLocalDpi xmlns:a14="http://schemas.microsoft.com/office/drawing/2010/main" val="0"/>
+              </a:ext>
+            </a:extLst>
+          </a:blip>
+          <a:stretch>
+            <a:fillRect/>
+          </a:stretch>
+        </p:blipFill>
+        <p:spPr>
+          <a:xfrm>
+            <a:off x="1950697" y="1761451"/>
+            <a:ext cx="8290605" cy="4216617"/>
+          </a:xfrm>
+          <a:prstGeom prst="rect">
+            <a:avLst/>
+          </a:prstGeom>
+        </p:spPr>
+      </p:pic>
+    </p:spTree>
+    <p:custDataLst>
+      <p:tags r:id="rId1"/>
+    </p:custDataLst>
+    <p:extLst>
+      <p:ext uri="{BB962C8B-B14F-4D97-AF65-F5344CB8AC3E}">
+        <p14:creationId xmlns:p14="http://schemas.microsoft.com/office/powerpoint/2010/main" val="1294054836"/>
+      </p:ext>
+    </p:extLst>
+  </p:cSld>
+  <p:clrMapOvr>
+    <a:masterClrMapping/>
+  </p:clrMapOvr>
+  <p:timing>
+    <p:tnLst>
+      <p:par>
+        <p:cTn id="1" dur="indefinite" restart="never" nodeType="tmRoot">
+          <p:childTnLst>
+            <p:seq concurrent="1" nextAc="seek">
+              <p:cTn id="2" dur="indefinite" nodeType="mainSeq">
+                <p:childTnLst>
+                  <p:par>
+                    <p:cTn id="3" fill="hold">
+                      <p:stCondLst>
+                        <p:cond delay="indefinite"/>
+                      </p:stCondLst>
+                      <p:childTnLst>
+                        <p:par>
+                          <p:cTn id="4" fill="hold">
+                            <p:stCondLst>
+                              <p:cond delay="0"/>
+                            </p:stCondLst>
+                            <p:childTnLst>
+                              <p:par>
+                                <p:cTn id="5" presetID="10" presetClass="entr" presetSubtype="0" fill="hold" grpId="0" nodeType="clickEffect">
+                                  <p:stCondLst>
+                                    <p:cond delay="0"/>
+                                  </p:stCondLst>
+                                  <p:childTnLst>
+                                    <p:set>
+                                      <p:cBhvr>
+                                        <p:cTn id="6" dur="1" fill="hold">
+                                          <p:stCondLst>
+                                            <p:cond delay="0"/>
+                                          </p:stCondLst>
+                                        </p:cTn>
+                                        <p:tgtEl>
+                                          <p:spTgt spid="4"/>
+                                        </p:tgtEl>
+                                        <p:attrNameLst>
+                                          <p:attrName>style.visibility</p:attrName>
+                                        </p:attrNameLst>
+                                      </p:cBhvr>
+                                      <p:to>
+                                        <p:strVal val="visible"/>
+                                      </p:to>
+                                    </p:set>
+                                    <p:animEffect transition="in" filter="fade">
+                                      <p:cBhvr>
+                                        <p:cTn id="7" dur="500"/>
+                                        <p:tgtEl>
+                                          <p:spTgt spid="4"/>
+                                        </p:tgtEl>
+                                      </p:cBhvr>
+                                    </p:animEffect>
+                                  </p:childTnLst>
+                                </p:cTn>
+                              </p:par>
+                              <p:par>
+                                <p:cTn id="8" presetID="10" presetClass="entr" presetSubtype="0" fill="hold" nodeType="withEffect">
+                                  <p:stCondLst>
+                                    <p:cond delay="0"/>
+                                  </p:stCondLst>
+                                  <p:childTnLst>
+                                    <p:set>
+                                      <p:cBhvr>
+                                        <p:cTn id="9" dur="1" fill="hold">
+                                          <p:stCondLst>
+                                            <p:cond delay="0"/>
+                                          </p:stCondLst>
+                                        </p:cTn>
+                                        <p:tgtEl>
+                                          <p:spTgt spid="6"/>
+                                        </p:tgtEl>
+                                        <p:attrNameLst>
+                                          <p:attrName>style.visibility</p:attrName>
+                                        </p:attrNameLst>
+                                      </p:cBhvr>
+                                      <p:to>
+                                        <p:strVal val="visible"/>
+                                      </p:to>
+                                    </p:set>
+                                    <p:animEffect transition="in" filter="fade">
+                                      <p:cBhvr>
+                                        <p:cTn id="10" dur="500"/>
+                                        <p:tgtEl>
+                                          <p:spTgt spid="6"/>
+                                        </p:tgtEl>
+                                      </p:cBhvr>
+                                    </p:animEffect>
+                                  </p:childTnLst>
+                                </p:cTn>
+                              </p:par>
+                            </p:childTnLst>
+                          </p:cTn>
+                        </p:par>
+                      </p:childTnLst>
+                    </p:cTn>
+                  </p:par>
+                </p:childTnLst>
+              </p:cTn>
+              <p:prevCondLst>
+                <p:cond evt="onPrev" delay="0">
+                  <p:tgtEl>
+                    <p:sldTgt/>
+                  </p:tgtEl>
+                </p:cond>
+              </p:prevCondLst>
+              <p:nextCondLst>
+                <p:cond evt="onNext" delay="0">
+                  <p:tgtEl>
+                    <p:sldTgt/>
+                  </p:tgtEl>
+                </p:cond>
+              </p:nextCondLst>
+            </p:seq>
+          </p:childTnLst>
+        </p:cTn>
+      </p:par>
+    </p:tnLst>
+    <p:bldLst>
+      <p:bldP spid="4" grpId="0"/>
+    </p:bldLst>
+  </p:timing>
+</p:sld>
+</file>
+
+<file path=ppt/slides/slide12.xml><?xml version="1.0" encoding="utf-8"?>
+<p:sld xmlns:a="http://schemas.openxmlformats.org/drawingml/2006/main" xmlns:r="http://schemas.openxmlformats.org/officeDocument/2006/relationships" xmlns:p="http://schemas.openxmlformats.org/presentationml/2006/main">
+  <p:cSld>
+    <p:spTree>
+      <p:nvGrpSpPr>
         <p:cNvPr id="1" name="">
           <a:extLst>
             <a:ext uri="{FF2B5EF4-FFF2-40B4-BE49-F238E27FC236}">
@@ -6239,7 +6511,7 @@
 </p:sld>
 </file>
 
-<file path=ppt/slides/slide12.xml><?xml version="1.0" encoding="utf-8"?>
+<file path=ppt/slides/slide13.xml><?xml version="1.0" encoding="utf-8"?>
 <p:sld xmlns:a="http://schemas.openxmlformats.org/drawingml/2006/main" xmlns:r="http://schemas.openxmlformats.org/officeDocument/2006/relationships" xmlns:p="http://schemas.openxmlformats.org/presentationml/2006/main">
   <p:cSld>
     <p:spTree>
@@ -6420,7 +6692,7 @@
           <p:nvPr/>
         </p:nvPicPr>
         <p:blipFill>
-          <a:blip r:embed="rId2">
+          <a:blip r:embed="rId3">
             <a:extLst>
               <a:ext uri="{28A0092B-C50C-407E-A947-70E740481C1C}">
                 <a14:useLocalDpi xmlns:a14="http://schemas.microsoft.com/office/drawing/2010/main" val="0"/>
@@ -6648,6 +6920,9 @@
         </p:txBody>
       </p:sp>
     </p:spTree>
+    <p:custDataLst>
+      <p:tags r:id="rId1"/>
+    </p:custDataLst>
     <p:extLst>
       <p:ext uri="{BB962C8B-B14F-4D97-AF65-F5344CB8AC3E}">
         <p14:creationId xmlns:p14="http://schemas.microsoft.com/office/powerpoint/2010/main" val="1611073301"/>
@@ -6906,7 +7181,7 @@
           <p:nvPr/>
         </p:nvPicPr>
         <p:blipFill>
-          <a:blip r:embed="rId2">
+          <a:blip r:embed="rId3">
             <a:extLst>
               <a:ext uri="{28A0092B-C50C-407E-A947-70E740481C1C}">
                 <a14:useLocalDpi xmlns:a14="http://schemas.microsoft.com/office/drawing/2010/main" val="0"/>
@@ -6981,7 +7256,7 @@
           <p:nvPr/>
         </p:nvPicPr>
         <p:blipFill>
-          <a:blip r:embed="rId3">
+          <a:blip r:embed="rId4">
             <a:extLst>
               <a:ext uri="{28A0092B-C50C-407E-A947-70E740481C1C}">
                 <a14:useLocalDpi xmlns:a14="http://schemas.microsoft.com/office/drawing/2010/main" val="0"/>
@@ -7148,6 +7423,9 @@
         </p:txBody>
       </p:sp>
     </p:spTree>
+    <p:custDataLst>
+      <p:tags r:id="rId1"/>
+    </p:custDataLst>
     <p:extLst>
       <p:ext uri="{BB962C8B-B14F-4D97-AF65-F5344CB8AC3E}">
         <p14:creationId xmlns:p14="http://schemas.microsoft.com/office/powerpoint/2010/main" val="697871414"/>
@@ -7355,7 +7633,7 @@
           <p:nvPr/>
         </p:nvPicPr>
         <p:blipFill>
-          <a:blip r:embed="rId2">
+          <a:blip r:embed="rId3">
             <a:extLst>
               <a:ext uri="{28A0092B-C50C-407E-A947-70E740481C1C}">
                 <a14:useLocalDpi xmlns:a14="http://schemas.microsoft.com/office/drawing/2010/main" val="0"/>
@@ -7421,42 +7699,6 @@
             <a:extLst>
               <a:ext uri="{FF2B5EF4-FFF2-40B4-BE49-F238E27FC236}">
                 <a16:creationId xmlns:a16="http://schemas.microsoft.com/office/drawing/2014/main" id="{ED90DF35-8D26-A2D5-B479-00E553777F13}"/>
-              </a:ext>
-            </a:extLst>
-          </p:cNvPr>
-          <p:cNvPicPr>
-            <a:picLocks noChangeAspect="1"/>
-          </p:cNvPicPr>
-          <p:nvPr/>
-        </p:nvPicPr>
-        <p:blipFill>
-          <a:blip r:embed="rId3">
-            <a:extLst>
-              <a:ext uri="{28A0092B-C50C-407E-A947-70E740481C1C}">
-                <a14:useLocalDpi xmlns:a14="http://schemas.microsoft.com/office/drawing/2010/main" val="0"/>
-              </a:ext>
-            </a:extLst>
-          </a:blip>
-          <a:stretch>
-            <a:fillRect/>
-          </a:stretch>
-        </p:blipFill>
-        <p:spPr>
-          <a:xfrm>
-            <a:off x="413408" y="1622330"/>
-            <a:ext cx="5374075" cy="5046099"/>
-          </a:xfrm>
-          <a:prstGeom prst="rect">
-            <a:avLst/>
-          </a:prstGeom>
-        </p:spPr>
-      </p:pic>
-      <p:pic>
-        <p:nvPicPr>
-          <p:cNvPr id="7" name="Picture 6" descr="A computer screen shot of a program code&#10;&#10;AI-generated content may be incorrect.">
-            <a:extLst>
-              <a:ext uri="{FF2B5EF4-FFF2-40B4-BE49-F238E27FC236}">
-                <a16:creationId xmlns:a16="http://schemas.microsoft.com/office/drawing/2014/main" id="{D96C60AF-067B-A92D-CE79-0A1AD812765A}"/>
               </a:ext>
             </a:extLst>
           </p:cNvPr>
@@ -7479,15 +7721,54 @@
         </p:blipFill>
         <p:spPr>
           <a:xfrm>
-            <a:off x="6200891" y="1622329"/>
-            <a:ext cx="5374075" cy="5046100"/>
+            <a:off x="413408" y="1622330"/>
+            <a:ext cx="5374075" cy="5046099"/>
           </a:xfrm>
           <a:prstGeom prst="rect">
             <a:avLst/>
           </a:prstGeom>
         </p:spPr>
       </p:pic>
+      <p:pic>
+        <p:nvPicPr>
+          <p:cNvPr id="7" name="Picture 6" descr="A computer screen shot of a program code&#10;&#10;AI-generated content may be incorrect.">
+            <a:extLst>
+              <a:ext uri="{FF2B5EF4-FFF2-40B4-BE49-F238E27FC236}">
+                <a16:creationId xmlns:a16="http://schemas.microsoft.com/office/drawing/2014/main" id="{D96C60AF-067B-A92D-CE79-0A1AD812765A}"/>
+              </a:ext>
+            </a:extLst>
+          </p:cNvPr>
+          <p:cNvPicPr>
+            <a:picLocks noChangeAspect="1"/>
+          </p:cNvPicPr>
+          <p:nvPr/>
+        </p:nvPicPr>
+        <p:blipFill>
+          <a:blip r:embed="rId5">
+            <a:extLst>
+              <a:ext uri="{28A0092B-C50C-407E-A947-70E740481C1C}">
+                <a14:useLocalDpi xmlns:a14="http://schemas.microsoft.com/office/drawing/2010/main" val="0"/>
+              </a:ext>
+            </a:extLst>
+          </a:blip>
+          <a:stretch>
+            <a:fillRect/>
+          </a:stretch>
+        </p:blipFill>
+        <p:spPr>
+          <a:xfrm>
+            <a:off x="6200891" y="1622329"/>
+            <a:ext cx="5374075" cy="5046100"/>
+          </a:xfrm>
+          <a:prstGeom prst="rect">
+            <a:avLst/>
+          </a:prstGeom>
+        </p:spPr>
+      </p:pic>
     </p:spTree>
+    <p:custDataLst>
+      <p:tags r:id="rId1"/>
+    </p:custDataLst>
     <p:extLst>
       <p:ext uri="{BB962C8B-B14F-4D97-AF65-F5344CB8AC3E}">
         <p14:creationId xmlns:p14="http://schemas.microsoft.com/office/powerpoint/2010/main" val="332038390"/>
@@ -7694,7 +7975,7 @@
           <p:nvPr/>
         </p:nvPicPr>
         <p:blipFill>
-          <a:blip r:embed="rId2">
+          <a:blip r:embed="rId3">
             <a:extLst>
               <a:ext uri="{28A0092B-C50C-407E-A947-70E740481C1C}">
                 <a14:useLocalDpi xmlns:a14="http://schemas.microsoft.com/office/drawing/2010/main" val="0"/>
@@ -8025,6 +8306,9 @@
         </p:txBody>
       </p:sp>
     </p:spTree>
+    <p:custDataLst>
+      <p:tags r:id="rId1"/>
+    </p:custDataLst>
     <p:extLst>
       <p:ext uri="{BB962C8B-B14F-4D97-AF65-F5344CB8AC3E}">
         <p14:creationId xmlns:p14="http://schemas.microsoft.com/office/powerpoint/2010/main" val="2208408078"/>
@@ -8164,6 +8448,224 @@
   <p:cSld>
     <p:spTree>
       <p:nvGrpSpPr>
+        <p:cNvPr id="1" name=""/>
+        <p:cNvGrpSpPr/>
+        <p:nvPr/>
+      </p:nvGrpSpPr>
+      <p:grpSpPr>
+        <a:xfrm>
+          <a:off x="0" y="0"/>
+          <a:ext cx="0" cy="0"/>
+          <a:chOff x="0" y="0"/>
+          <a:chExt cx="0" cy="0"/>
+        </a:xfrm>
+      </p:grpSpPr>
+      <p:pic>
+        <p:nvPicPr>
+          <p:cNvPr id="5" name="Picture 4" descr="A computer screen with a blue background&#10;&#10;AI-generated content may be incorrect.">
+            <a:extLst>
+              <a:ext uri="{FF2B5EF4-FFF2-40B4-BE49-F238E27FC236}">
+                <a16:creationId xmlns:a16="http://schemas.microsoft.com/office/drawing/2014/main" id="{B23F72BB-F009-97BF-88F2-F3EEF026B664}"/>
+              </a:ext>
+            </a:extLst>
+          </p:cNvPr>
+          <p:cNvPicPr>
+            <a:picLocks noChangeAspect="1"/>
+          </p:cNvPicPr>
+          <p:nvPr/>
+        </p:nvPicPr>
+        <p:blipFill>
+          <a:blip r:embed="rId2">
+            <a:extLst>
+              <a:ext uri="{28A0092B-C50C-407E-A947-70E740481C1C}">
+                <a14:useLocalDpi xmlns:a14="http://schemas.microsoft.com/office/drawing/2010/main" val="0"/>
+              </a:ext>
+            </a:extLst>
+          </a:blip>
+          <a:stretch>
+            <a:fillRect/>
+          </a:stretch>
+        </p:blipFill>
+        <p:spPr>
+          <a:xfrm>
+            <a:off x="0" y="0"/>
+            <a:ext cx="12192000" cy="6858000"/>
+          </a:xfrm>
+          <a:prstGeom prst="rect">
+            <a:avLst/>
+          </a:prstGeom>
+        </p:spPr>
+      </p:pic>
+      <p:sp>
+        <p:nvSpPr>
+          <p:cNvPr id="7" name="TextBox 6">
+            <a:extLst>
+              <a:ext uri="{FF2B5EF4-FFF2-40B4-BE49-F238E27FC236}">
+                <a16:creationId xmlns:a16="http://schemas.microsoft.com/office/drawing/2014/main" id="{CE394CDB-A17F-3551-3653-44B864F97C95}"/>
+              </a:ext>
+            </a:extLst>
+          </p:cNvPr>
+          <p:cNvSpPr txBox="1"/>
+          <p:nvPr/>
+        </p:nvSpPr>
+        <p:spPr>
+          <a:xfrm>
+            <a:off x="256478" y="211201"/>
+            <a:ext cx="9846525" cy="646331"/>
+          </a:xfrm>
+          <a:prstGeom prst="rect">
+            <a:avLst/>
+          </a:prstGeom>
+          <a:noFill/>
+        </p:spPr>
+        <p:txBody>
+          <a:bodyPr wrap="square">
+            <a:spAutoFit/>
+          </a:bodyPr>
+          <a:lstStyle/>
+          <a:p>
+            <a:r>
+              <a:rPr lang="en-US" sz="3600" b="1" dirty="0">
+                <a:solidFill>
+                  <a:schemeClr val="bg1"/>
+                </a:solidFill>
+              </a:rPr>
+              <a:t>Image Processing Transformations Output</a:t>
+            </a:r>
+            <a:endParaRPr lang="en-US" sz="3600" dirty="0">
+              <a:solidFill>
+                <a:schemeClr val="bg1"/>
+              </a:solidFill>
+            </a:endParaRPr>
+          </a:p>
+        </p:txBody>
+      </p:sp>
+      <p:pic>
+        <p:nvPicPr>
+          <p:cNvPr id="9" name="Picture 8" descr="A white background with black text&#10;&#10;AI-generated content may be incorrect.">
+            <a:extLst>
+              <a:ext uri="{FF2B5EF4-FFF2-40B4-BE49-F238E27FC236}">
+                <a16:creationId xmlns:a16="http://schemas.microsoft.com/office/drawing/2014/main" id="{70397984-115F-1556-6F2B-CECDC7C260E8}"/>
+              </a:ext>
+            </a:extLst>
+          </p:cNvPr>
+          <p:cNvPicPr>
+            <a:picLocks noChangeAspect="1"/>
+          </p:cNvPicPr>
+          <p:nvPr/>
+        </p:nvPicPr>
+        <p:blipFill>
+          <a:blip r:embed="rId3">
+            <a:extLst>
+              <a:ext uri="{28A0092B-C50C-407E-A947-70E740481C1C}">
+                <a14:useLocalDpi xmlns:a14="http://schemas.microsoft.com/office/drawing/2010/main" val="0"/>
+              </a:ext>
+            </a:extLst>
+          </a:blip>
+          <a:stretch>
+            <a:fillRect/>
+          </a:stretch>
+        </p:blipFill>
+        <p:spPr>
+          <a:xfrm>
+            <a:off x="376470" y="1684589"/>
+            <a:ext cx="3113862" cy="3488821"/>
+          </a:xfrm>
+          <a:prstGeom prst="rect">
+            <a:avLst/>
+          </a:prstGeom>
+        </p:spPr>
+      </p:pic>
+      <p:pic>
+        <p:nvPicPr>
+          <p:cNvPr id="11" name="Picture 10" descr="A white card with black text&#10;&#10;AI-generated content may be incorrect.">
+            <a:extLst>
+              <a:ext uri="{FF2B5EF4-FFF2-40B4-BE49-F238E27FC236}">
+                <a16:creationId xmlns:a16="http://schemas.microsoft.com/office/drawing/2014/main" id="{B2C13DD7-3E21-E4CA-F986-D28D271F4FC2}"/>
+              </a:ext>
+            </a:extLst>
+          </p:cNvPr>
+          <p:cNvPicPr>
+            <a:picLocks noChangeAspect="1"/>
+          </p:cNvPicPr>
+          <p:nvPr/>
+        </p:nvPicPr>
+        <p:blipFill>
+          <a:blip r:embed="rId4">
+            <a:extLst>
+              <a:ext uri="{28A0092B-C50C-407E-A947-70E740481C1C}">
+                <a14:useLocalDpi xmlns:a14="http://schemas.microsoft.com/office/drawing/2010/main" val="0"/>
+              </a:ext>
+            </a:extLst>
+          </a:blip>
+          <a:stretch>
+            <a:fillRect/>
+          </a:stretch>
+        </p:blipFill>
+        <p:spPr>
+          <a:xfrm>
+            <a:off x="4027463" y="1684589"/>
+            <a:ext cx="3555367" cy="3400367"/>
+          </a:xfrm>
+          <a:prstGeom prst="rect">
+            <a:avLst/>
+          </a:prstGeom>
+        </p:spPr>
+      </p:pic>
+      <p:pic>
+        <p:nvPicPr>
+          <p:cNvPr id="13" name="Picture 12" descr="A black text on a white background&#10;&#10;AI-generated content may be incorrect.">
+            <a:extLst>
+              <a:ext uri="{FF2B5EF4-FFF2-40B4-BE49-F238E27FC236}">
+                <a16:creationId xmlns:a16="http://schemas.microsoft.com/office/drawing/2014/main" id="{C3C839B1-841F-873E-3496-AEB3E032CEF7}"/>
+              </a:ext>
+            </a:extLst>
+          </p:cNvPr>
+          <p:cNvPicPr>
+            <a:picLocks noChangeAspect="1"/>
+          </p:cNvPicPr>
+          <p:nvPr/>
+        </p:nvPicPr>
+        <p:blipFill>
+          <a:blip r:embed="rId5">
+            <a:extLst>
+              <a:ext uri="{28A0092B-C50C-407E-A947-70E740481C1C}">
+                <a14:useLocalDpi xmlns:a14="http://schemas.microsoft.com/office/drawing/2010/main" val="0"/>
+              </a:ext>
+            </a:extLst>
+          </a:blip>
+          <a:stretch>
+            <a:fillRect/>
+          </a:stretch>
+        </p:blipFill>
+        <p:spPr>
+          <a:xfrm>
+            <a:off x="8337395" y="1528651"/>
+            <a:ext cx="2887824" cy="3858322"/>
+          </a:xfrm>
+          <a:prstGeom prst="rect">
+            <a:avLst/>
+          </a:prstGeom>
+        </p:spPr>
+      </p:pic>
+    </p:spTree>
+    <p:extLst>
+      <p:ext uri="{BB962C8B-B14F-4D97-AF65-F5344CB8AC3E}">
+        <p14:creationId xmlns:p14="http://schemas.microsoft.com/office/powerpoint/2010/main" val="2052731438"/>
+      </p:ext>
+    </p:extLst>
+  </p:cSld>
+  <p:clrMapOvr>
+    <a:masterClrMapping/>
+  </p:clrMapOvr>
+</p:sld>
+</file>
+
+<file path=ppt/slides/slide7.xml><?xml version="1.0" encoding="utf-8"?>
+<p:sld xmlns:a="http://schemas.openxmlformats.org/drawingml/2006/main" xmlns:r="http://schemas.openxmlformats.org/officeDocument/2006/relationships" xmlns:p="http://schemas.openxmlformats.org/presentationml/2006/main">
+  <p:cSld>
+    <p:spTree>
+      <p:nvGrpSpPr>
         <p:cNvPr id="1" name="">
           <a:extLst>
             <a:ext uri="{FF2B5EF4-FFF2-40B4-BE49-F238E27FC236}">
@@ -8197,7 +8699,7 @@
           <p:nvPr/>
         </p:nvPicPr>
         <p:blipFill>
-          <a:blip r:embed="rId2">
+          <a:blip r:embed="rId3">
             <a:extLst>
               <a:ext uri="{28A0092B-C50C-407E-A947-70E740481C1C}">
                 <a14:useLocalDpi xmlns:a14="http://schemas.microsoft.com/office/drawing/2010/main" val="0"/>
@@ -8272,7 +8774,7 @@
           <p:nvPr/>
         </p:nvPicPr>
         <p:blipFill>
-          <a:blip r:embed="rId3">
+          <a:blip r:embed="rId4">
             <a:extLst>
               <a:ext uri="{28A0092B-C50C-407E-A947-70E740481C1C}">
                 <a14:useLocalDpi xmlns:a14="http://schemas.microsoft.com/office/drawing/2010/main" val="0"/>
@@ -8294,6 +8796,9 @@
         </p:spPr>
       </p:pic>
     </p:spTree>
+    <p:custDataLst>
+      <p:tags r:id="rId1"/>
+    </p:custDataLst>
     <p:extLst>
       <p:ext uri="{BB962C8B-B14F-4D97-AF65-F5344CB8AC3E}">
         <p14:creationId xmlns:p14="http://schemas.microsoft.com/office/powerpoint/2010/main" val="4273845599"/>
@@ -8427,7 +8932,7 @@
 </p:sld>
 </file>
 
-<file path=ppt/slides/slide7.xml><?xml version="1.0" encoding="utf-8"?>
+<file path=ppt/slides/slide8.xml><?xml version="1.0" encoding="utf-8"?>
 <p:sld xmlns:a="http://schemas.openxmlformats.org/drawingml/2006/main" xmlns:r="http://schemas.openxmlformats.org/officeDocument/2006/relationships" xmlns:p="http://schemas.openxmlformats.org/presentationml/2006/main">
   <p:cSld>
     <p:spTree>
@@ -8465,7 +8970,7 @@
           <p:nvPr/>
         </p:nvPicPr>
         <p:blipFill>
-          <a:blip r:embed="rId2">
+          <a:blip r:embed="rId3">
             <a:extLst>
               <a:ext uri="{28A0092B-C50C-407E-A947-70E740481C1C}">
                 <a14:useLocalDpi xmlns:a14="http://schemas.microsoft.com/office/drawing/2010/main" val="0"/>
@@ -8781,6 +9286,9 @@
         </p:txBody>
       </p:sp>
     </p:spTree>
+    <p:custDataLst>
+      <p:tags r:id="rId1"/>
+    </p:custDataLst>
     <p:extLst>
       <p:ext uri="{BB962C8B-B14F-4D97-AF65-F5344CB8AC3E}">
         <p14:creationId xmlns:p14="http://schemas.microsoft.com/office/powerpoint/2010/main" val="1406709416"/>
@@ -8915,7 +9423,7 @@
 </p:sld>
 </file>
 
-<file path=ppt/slides/slide8.xml><?xml version="1.0" encoding="utf-8"?>
+<file path=ppt/slides/slide9.xml><?xml version="1.0" encoding="utf-8"?>
 <p:sld xmlns:a="http://schemas.openxmlformats.org/drawingml/2006/main" xmlns:r="http://schemas.openxmlformats.org/officeDocument/2006/relationships" xmlns:p="http://schemas.openxmlformats.org/presentationml/2006/main">
   <p:cSld>
     <p:spTree>
@@ -9214,266 +9722,58 @@
 </p:sld>
 </file>
 
-<file path=ppt/slides/slide9.xml><?xml version="1.0" encoding="utf-8"?>
-<p:sld xmlns:a="http://schemas.openxmlformats.org/drawingml/2006/main" xmlns:r="http://schemas.openxmlformats.org/officeDocument/2006/relationships" xmlns:p="http://schemas.openxmlformats.org/presentationml/2006/main">
-  <p:cSld>
-    <p:spTree>
-      <p:nvGrpSpPr>
-        <p:cNvPr id="1" name=""/>
-        <p:cNvGrpSpPr/>
-        <p:nvPr/>
-      </p:nvGrpSpPr>
-      <p:grpSpPr>
-        <a:xfrm>
-          <a:off x="0" y="0"/>
-          <a:ext cx="0" cy="0"/>
-          <a:chOff x="0" y="0"/>
-          <a:chExt cx="0" cy="0"/>
-        </a:xfrm>
-      </p:grpSpPr>
-      <p:pic>
-        <p:nvPicPr>
-          <p:cNvPr id="3" name="Picture 2" descr="A computer screen with a blue background&#10;&#10;AI-generated content may be incorrect.">
-            <a:extLst>
-              <a:ext uri="{FF2B5EF4-FFF2-40B4-BE49-F238E27FC236}">
-                <a16:creationId xmlns:a16="http://schemas.microsoft.com/office/drawing/2014/main" id="{CCAB805E-8BC0-187C-C05B-C1ABCE3BC391}"/>
-              </a:ext>
-            </a:extLst>
-          </p:cNvPr>
-          <p:cNvPicPr>
-            <a:picLocks noChangeAspect="1"/>
-          </p:cNvPicPr>
-          <p:nvPr/>
-        </p:nvPicPr>
-        <p:blipFill>
-          <a:blip r:embed="rId2">
-            <a:extLst>
-              <a:ext uri="{28A0092B-C50C-407E-A947-70E740481C1C}">
-                <a14:useLocalDpi xmlns:a14="http://schemas.microsoft.com/office/drawing/2010/main" val="0"/>
-              </a:ext>
-            </a:extLst>
-          </a:blip>
-          <a:stretch>
-            <a:fillRect/>
-          </a:stretch>
-        </p:blipFill>
-        <p:spPr>
-          <a:xfrm>
-            <a:off x="0" y="0"/>
-            <a:ext cx="12192000" cy="6958361"/>
-          </a:xfrm>
-          <a:prstGeom prst="rect">
-            <a:avLst/>
-          </a:prstGeom>
-        </p:spPr>
-      </p:pic>
-      <p:sp>
-        <p:nvSpPr>
-          <p:cNvPr id="4" name="TextBox 3">
-            <a:extLst>
-              <a:ext uri="{FF2B5EF4-FFF2-40B4-BE49-F238E27FC236}">
-                <a16:creationId xmlns:a16="http://schemas.microsoft.com/office/drawing/2014/main" id="{CCF86807-66AF-9FB0-9E5C-420F9854BE19}"/>
-              </a:ext>
-            </a:extLst>
-          </p:cNvPr>
-          <p:cNvSpPr txBox="1"/>
-          <p:nvPr/>
-        </p:nvSpPr>
-        <p:spPr>
-          <a:xfrm>
-            <a:off x="591015" y="557560"/>
-            <a:ext cx="5988205" cy="646331"/>
-          </a:xfrm>
-          <a:prstGeom prst="rect">
-            <a:avLst/>
-          </a:prstGeom>
-          <a:noFill/>
-        </p:spPr>
-        <p:txBody>
-          <a:bodyPr wrap="square" rtlCol="0">
-            <a:spAutoFit/>
-          </a:bodyPr>
-          <a:lstStyle/>
-          <a:p>
-            <a:r>
-              <a:rPr lang="en-US" sz="3600" b="1" dirty="0">
-                <a:solidFill>
-                  <a:schemeClr val="bg1"/>
-                </a:solidFill>
-              </a:rPr>
-              <a:t>Output of the Project:</a:t>
-            </a:r>
-          </a:p>
-        </p:txBody>
-      </p:sp>
-      <p:pic>
-        <p:nvPicPr>
-          <p:cNvPr id="6" name="Picture 5" descr="A screenshot of a computer program&#10;&#10;AI-generated content may be incorrect.">
-            <a:extLst>
-              <a:ext uri="{FF2B5EF4-FFF2-40B4-BE49-F238E27FC236}">
-                <a16:creationId xmlns:a16="http://schemas.microsoft.com/office/drawing/2014/main" id="{30AE157F-A35F-E44F-0D11-AAF92BF3F619}"/>
-              </a:ext>
-            </a:extLst>
-          </p:cNvPr>
-          <p:cNvPicPr>
-            <a:picLocks noChangeAspect="1"/>
-          </p:cNvPicPr>
-          <p:nvPr/>
-        </p:nvPicPr>
-        <p:blipFill>
-          <a:blip r:embed="rId3">
-            <a:extLst>
-              <a:ext uri="{28A0092B-C50C-407E-A947-70E740481C1C}">
-                <a14:useLocalDpi xmlns:a14="http://schemas.microsoft.com/office/drawing/2010/main" val="0"/>
-              </a:ext>
-            </a:extLst>
-          </a:blip>
-          <a:stretch>
-            <a:fillRect/>
-          </a:stretch>
-        </p:blipFill>
-        <p:spPr>
-          <a:xfrm>
-            <a:off x="1950697" y="1761451"/>
-            <a:ext cx="8290605" cy="4216617"/>
-          </a:xfrm>
-          <a:prstGeom prst="rect">
-            <a:avLst/>
-          </a:prstGeom>
-        </p:spPr>
-      </p:pic>
-    </p:spTree>
-    <p:extLst>
-      <p:ext uri="{BB962C8B-B14F-4D97-AF65-F5344CB8AC3E}">
-        <p14:creationId xmlns:p14="http://schemas.microsoft.com/office/powerpoint/2010/main" val="1294054836"/>
-      </p:ext>
-    </p:extLst>
-  </p:cSld>
-  <p:clrMapOvr>
-    <a:masterClrMapping/>
-  </p:clrMapOvr>
-  <p:timing>
-    <p:tnLst>
-      <p:par>
-        <p:cTn id="1" dur="indefinite" restart="never" nodeType="tmRoot">
-          <p:childTnLst>
-            <p:seq concurrent="1" nextAc="seek">
-              <p:cTn id="2" dur="indefinite" nodeType="mainSeq">
-                <p:childTnLst>
-                  <p:par>
-                    <p:cTn id="3" fill="hold">
-                      <p:stCondLst>
-                        <p:cond delay="indefinite"/>
-                      </p:stCondLst>
-                      <p:childTnLst>
-                        <p:par>
-                          <p:cTn id="4" fill="hold">
-                            <p:stCondLst>
-                              <p:cond delay="0"/>
-                            </p:stCondLst>
-                            <p:childTnLst>
-                              <p:par>
-                                <p:cTn id="5" presetID="10" presetClass="entr" presetSubtype="0" fill="hold" grpId="0" nodeType="clickEffect">
-                                  <p:stCondLst>
-                                    <p:cond delay="0"/>
-                                  </p:stCondLst>
-                                  <p:childTnLst>
-                                    <p:set>
-                                      <p:cBhvr>
-                                        <p:cTn id="6" dur="1" fill="hold">
-                                          <p:stCondLst>
-                                            <p:cond delay="0"/>
-                                          </p:stCondLst>
-                                        </p:cTn>
-                                        <p:tgtEl>
-                                          <p:spTgt spid="4"/>
-                                        </p:tgtEl>
-                                        <p:attrNameLst>
-                                          <p:attrName>style.visibility</p:attrName>
-                                        </p:attrNameLst>
-                                      </p:cBhvr>
-                                      <p:to>
-                                        <p:strVal val="visible"/>
-                                      </p:to>
-                                    </p:set>
-                                    <p:animEffect transition="in" filter="fade">
-                                      <p:cBhvr>
-                                        <p:cTn id="7" dur="500"/>
-                                        <p:tgtEl>
-                                          <p:spTgt spid="4"/>
-                                        </p:tgtEl>
-                                      </p:cBhvr>
-                                    </p:animEffect>
-                                  </p:childTnLst>
-                                </p:cTn>
-                              </p:par>
-                              <p:par>
-                                <p:cTn id="8" presetID="10" presetClass="entr" presetSubtype="0" fill="hold" nodeType="withEffect">
-                                  <p:stCondLst>
-                                    <p:cond delay="0"/>
-                                  </p:stCondLst>
-                                  <p:childTnLst>
-                                    <p:set>
-                                      <p:cBhvr>
-                                        <p:cTn id="9" dur="1" fill="hold">
-                                          <p:stCondLst>
-                                            <p:cond delay="0"/>
-                                          </p:stCondLst>
-                                        </p:cTn>
-                                        <p:tgtEl>
-                                          <p:spTgt spid="6"/>
-                                        </p:tgtEl>
-                                        <p:attrNameLst>
-                                          <p:attrName>style.visibility</p:attrName>
-                                        </p:attrNameLst>
-                                      </p:cBhvr>
-                                      <p:to>
-                                        <p:strVal val="visible"/>
-                                      </p:to>
-                                    </p:set>
-                                    <p:animEffect transition="in" filter="fade">
-                                      <p:cBhvr>
-                                        <p:cTn id="10" dur="500"/>
-                                        <p:tgtEl>
-                                          <p:spTgt spid="6"/>
-                                        </p:tgtEl>
-                                      </p:cBhvr>
-                                    </p:animEffect>
-                                  </p:childTnLst>
-                                </p:cTn>
-                              </p:par>
-                            </p:childTnLst>
-                          </p:cTn>
-                        </p:par>
-                      </p:childTnLst>
-                    </p:cTn>
-                  </p:par>
-                </p:childTnLst>
-              </p:cTn>
-              <p:prevCondLst>
-                <p:cond evt="onPrev" delay="0">
-                  <p:tgtEl>
-                    <p:sldTgt/>
-                  </p:tgtEl>
-                </p:cond>
-              </p:prevCondLst>
-              <p:nextCondLst>
-                <p:cond evt="onNext" delay="0">
-                  <p:tgtEl>
-                    <p:sldTgt/>
-                  </p:tgtEl>
-                </p:cond>
-              </p:nextCondLst>
-            </p:seq>
-          </p:childTnLst>
-        </p:cTn>
-      </p:par>
-    </p:tnLst>
-    <p:bldLst>
-      <p:bldP spid="4" grpId="0"/>
-    </p:bldLst>
-  </p:timing>
-</p:sld>
+<file path=ppt/tags/tag1.xml><?xml version="1.0" encoding="utf-8"?>
+<p:tagLst xmlns:a="http://schemas.openxmlformats.org/drawingml/2006/main" xmlns:r="http://schemas.openxmlformats.org/officeDocument/2006/relationships" xmlns:p="http://schemas.openxmlformats.org/presentationml/2006/main">
+  <p:tag name="TIMING" val="|1.3"/>
+</p:tagLst>
+</file>
+
+<file path=ppt/tags/tag2.xml><?xml version="1.0" encoding="utf-8"?>
+<p:tagLst xmlns:a="http://schemas.openxmlformats.org/drawingml/2006/main" xmlns:r="http://schemas.openxmlformats.org/officeDocument/2006/relationships" xmlns:p="http://schemas.openxmlformats.org/presentationml/2006/main">
+  <p:tag name="TIMING" val="|0.3"/>
+</p:tagLst>
+</file>
+
+<file path=ppt/tags/tag3.xml><?xml version="1.0" encoding="utf-8"?>
+<p:tagLst xmlns:a="http://schemas.openxmlformats.org/drawingml/2006/main" xmlns:r="http://schemas.openxmlformats.org/officeDocument/2006/relationships" xmlns:p="http://schemas.openxmlformats.org/presentationml/2006/main">
+  <p:tag name="TIMING" val="|0"/>
+</p:tagLst>
+</file>
+
+<file path=ppt/tags/tag4.xml><?xml version="1.0" encoding="utf-8"?>
+<p:tagLst xmlns:a="http://schemas.openxmlformats.org/drawingml/2006/main" xmlns:r="http://schemas.openxmlformats.org/officeDocument/2006/relationships" xmlns:p="http://schemas.openxmlformats.org/presentationml/2006/main">
+  <p:tag name="TIMING" val="|0.5"/>
+</p:tagLst>
+</file>
+
+<file path=ppt/tags/tag5.xml><?xml version="1.0" encoding="utf-8"?>
+<p:tagLst xmlns:a="http://schemas.openxmlformats.org/drawingml/2006/main" xmlns:r="http://schemas.openxmlformats.org/officeDocument/2006/relationships" xmlns:p="http://schemas.openxmlformats.org/presentationml/2006/main">
+  <p:tag name="TIMING" val="|0.4"/>
+</p:tagLst>
+</file>
+
+<file path=ppt/tags/tag6.xml><?xml version="1.0" encoding="utf-8"?>
+<p:tagLst xmlns:a="http://schemas.openxmlformats.org/drawingml/2006/main" xmlns:r="http://schemas.openxmlformats.org/officeDocument/2006/relationships" xmlns:p="http://schemas.openxmlformats.org/presentationml/2006/main">
+  <p:tag name="TIMING" val="|1.4"/>
+</p:tagLst>
+</file>
+
+<file path=ppt/tags/tag7.xml><?xml version="1.0" encoding="utf-8"?>
+<p:tagLst xmlns:a="http://schemas.openxmlformats.org/drawingml/2006/main" xmlns:r="http://schemas.openxmlformats.org/officeDocument/2006/relationships" xmlns:p="http://schemas.openxmlformats.org/presentationml/2006/main">
+  <p:tag name="TIMING" val="|0.9"/>
+</p:tagLst>
+</file>
+
+<file path=ppt/tags/tag8.xml><?xml version="1.0" encoding="utf-8"?>
+<p:tagLst xmlns:a="http://schemas.openxmlformats.org/drawingml/2006/main" xmlns:r="http://schemas.openxmlformats.org/officeDocument/2006/relationships" xmlns:p="http://schemas.openxmlformats.org/presentationml/2006/main">
+  <p:tag name="TIMING" val="|0.6"/>
+</p:tagLst>
+</file>
+
+<file path=ppt/tags/tag9.xml><?xml version="1.0" encoding="utf-8"?>
+<p:tagLst xmlns:a="http://schemas.openxmlformats.org/drawingml/2006/main" xmlns:r="http://schemas.openxmlformats.org/officeDocument/2006/relationships" xmlns:p="http://schemas.openxmlformats.org/presentationml/2006/main">
+  <p:tag name="TIMING" val="|0.6"/>
+</p:tagLst>
 </file>
 
 <file path=ppt/theme/theme1.xml><?xml version="1.0" encoding="utf-8"?>

</xml_diff>